<commit_message>
Update the pitch deck: masked pair and real change wording
</commit_message>
<xml_diff>
--- a/docs/Receipts_ExaThon_2026_Deck.pptx
+++ b/docs/Receipts_ExaThon_2026_Deck.pptx
@@ -136,38 +136,38 @@
   <p:extLst>
     <p:ext uri="{521415D9-36F7-43E2-AB2F-B90AF26B5E84}">
       <p14:sectionLst xmlns:p14="http://schemas.microsoft.com/office/powerpoint/2010/main">
-        <p14:section name="Opening" id="{6847bb6e-d95b-508d-43f6-750c7e97ad98}">
+        <p14:section name="Opening" id="{87476889-f31a-f551-18ab-14b0ffb99f29}">
           <p14:sldIdLst>
             <p14:sldId id="256"/>
             <p14:sldId id="257"/>
           </p14:sldIdLst>
         </p14:section>
-        <p14:section name="The problem" id="{fac54bf4-ad6c-fac7-3cf4-84b32acb08ea}">
+        <p14:section name="The problem" id="{959a0914-96e8-5fdc-e390-6bfcf740ce78}">
           <p14:sldIdLst>
             <p14:sldId id="258"/>
             <p14:sldId id="259"/>
           </p14:sldIdLst>
         </p14:section>
-        <p14:section name="Landscape" id="{848c4dcb-7cef-8259-bff8-dfe6fe44dd3f}">
+        <p14:section name="Landscape" id="{d035a2d7-b625-54e4-60c5-5bddf50d322b}">
           <p14:sldIdLst>
             <p14:sldId id="260"/>
             <p14:sldId id="261"/>
           </p14:sldIdLst>
         </p14:section>
-        <p14:section name="How it works" id="{9c0ae6f7-0687-c638-7dc9-aec97e600d32}">
+        <p14:section name="How it works" id="{e5a3cf4c-f5ee-377a-a3f1-df98ce1a3784}">
           <p14:sldIdLst>
             <p14:sldId id="262"/>
             <p14:sldId id="263"/>
           </p14:sldIdLst>
         </p14:section>
-        <p14:section name="Three cases" id="{d29414b7-ddff-a2e9-c7a7-d39564c85338}">
+        <p14:section name="Three cases" id="{8e1ab72c-d50f-d156-13ea-6d79b1967690}">
           <p14:sldIdLst>
             <p14:sldId id="264"/>
             <p14:sldId id="265"/>
             <p14:sldId id="266"/>
           </p14:sldIdLst>
         </p14:section>
-        <p14:section name="Agents and Exasol" id="{05b56891-b1de-d1d3-7bea-a3e6726f4c71}">
+        <p14:section name="Agents and Exasol" id="{5ec3c0b4-b476-9047-12e3-347d63404603}">
           <p14:sldIdLst>
             <p14:sldId id="267"/>
             <p14:sldId id="268"/>
@@ -176,7 +176,7 @@
             <p14:sldId id="271"/>
           </p14:sldIdLst>
         </p14:section>
-        <p14:section name="Evidence" id="{60e86b94-61c8-8233-6901-0a280ba7ef12}">
+        <p14:section name="Evidence" id="{9f3d54b9-039b-3715-06fc-42ce30c867f4}">
           <p14:sldIdLst>
             <p14:sldId id="272"/>
             <p14:sldId id="273"/>
@@ -187,14 +187,14 @@
             <p14:sldId id="278"/>
           </p14:sldIdLst>
         </p14:section>
-        <p14:section name="Honesty and next steps" id="{7dccba64-7f08-a08f-1984-6fcc9e334485}">
+        <p14:section name="Honesty and next steps" id="{6517da96-50cc-68d4-432c-a3eebb6c8350}">
           <p14:sldIdLst>
             <p14:sldId id="279"/>
             <p14:sldId id="280"/>
             <p14:sldId id="281"/>
           </p14:sldIdLst>
         </p14:section>
-        <p14:section name="References" id="{a62e98c2-b8e6-e8c8-b13a-30e2758d5007}">
+        <p14:section name="References" id="{900a5647-0024-7a8e-8cb2-9d8157824363}">
           <p14:sldIdLst>
             <p14:sldId id="282"/>
             <p14:sldId id="283"/>
@@ -7389,7 +7389,7 @@
                   <a:schemeClr val="bg1"/>
                 </a:solidFill>
               </a:rPr>
-              <a:t>Case 2: two faults that cancel out</a:t>
+              <a:t>Case 2: two faults that partly cancel</a:t>
             </a:r>
             <a:endParaRPr lang="en-US" sz="3400" dirty="0"/>
           </a:p>
@@ -7486,7 +7486,7 @@
                 <a:ea typeface="+mj-lt" pitchFamily="34" charset="-122"/>
                 <a:cs typeface="+mj-lt" pitchFamily="34" charset="-120"/>
               </a:rPr>
-              <a:t>Total moved only +1.8%</a:t>
+              <a:t>Total moved only +1.8% in this run</a:t>
             </a:r>
             <a:endParaRPr lang="en-US" sz="1800" dirty="0"/>
           </a:p>
@@ -7522,7 +7522,7 @@
                   <a:schemeClr val="tx1"/>
                 </a:solidFill>
               </a:rPr>
-              <a:t>Inside the normal range of 3.12 to 3.53 crore. The dashboard would publish it.</a:t>
+              <a:t>Inside the normal range of 3.12 to 3.53 crore, so the dashboard would publish it. Over the 5 eval seeds the total was inside the range in 1.</a:t>
             </a:r>
             <a:endParaRPr lang="en-US" sz="1400" dirty="0"/>
           </a:p>
@@ -7595,7 +7595,7 @@
                 <a:ea typeface="+mj-lt" pitchFamily="34" charset="-122"/>
                 <a:cs typeface="+mj-lt" pitchFamily="34" charset="-120"/>
               </a:rPr>
-              <a:t>A threshold alert stays silent</a:t>
+              <a:t>A threshold alert never names a cause</a:t>
             </a:r>
             <a:endParaRPr lang="en-US" sz="1800" dirty="0"/>
           </a:p>
@@ -7631,7 +7631,7 @@
                   <a:schemeClr val="tx1"/>
                 </a:solidFill>
               </a:rPr>
-              <a:t>Across 50 runs it missed all 40 planted causes [13].</a:t>
+              <a:t>It held 4 of the 5 masked pairs without a cause and missed all 40 planted causes across 50 runs [13].</a:t>
             </a:r>
             <a:endParaRPr lang="en-US" sz="1400" dirty="0"/>
           </a:p>
@@ -7776,7 +7776,7 @@
                   <a:srgbClr val="5B7684"/>
                 </a:solidFill>
               </a:rPr>
-              <a:t>Gateway B down 31%, gateway A up 22%: the slices disagree, the total hides it [16].</a:t>
+              <a:t>Gateway B down 31%, gateway A up 22%: the slices disagree, so the net total moves little [16].</a:t>
             </a:r>
             <a:endParaRPr lang="en-US" sz="1100" dirty="0"/>
           </a:p>
@@ -8292,7 +8292,7 @@
                 <a:ea typeface="+mj-lt" pitchFamily="34" charset="-122"/>
                 <a:cs typeface="+mj-lt" pitchFamily="34" charset="-120"/>
               </a:rPr>
-              <a:t>Verdict: published as a verified real change</a:t>
+              <a:t>Verdict: published as a real change, no fault found</a:t>
             </a:r>
             <a:endParaRPr lang="en-US" sz="1600" dirty="0"/>
           </a:p>
@@ -13859,7 +13859,7 @@
                   <a:schemeClr val="tx1"/>
                 </a:solidFill>
               </a:rPr>
-              <a:t>A x100 unit change on 2% of one gateway was published as a verified real change, 6.5% off. The unit check compared medians, and 2% of rows does not move a median.</a:t>
+              <a:t>A x100 unit change on 2% of one gateway was published as a real change, 6.5% off. The unit check compared medians, and 2% of rows does not move a median.</a:t>
             </a:r>
             <a:endParaRPr lang="en-US" sz="1200" dirty="0"/>
           </a:p>
@@ -17430,7 +17430,7 @@
                   <a:srgbClr val="5B7684"/>
                 </a:solidFill>
               </a:rPr>
-              <a:t>Teal: no incident.  Orange: verified real change.  Dark outline: a fault we planted on that day, caught.</a:t>
+              <a:t>Teal: no incident.  Orange: real change, no fault found.  Dark outline: a fault we planted on that day, caught.</a:t>
             </a:r>
             <a:endParaRPr lang="en-US" sz="1100" dirty="0"/>
           </a:p>
@@ -17539,7 +17539,7 @@
                   <a:schemeClr val="tx1"/>
                 </a:solidFill>
               </a:rPr>
-              <a:t>NYC yellow taxi trips, Jan to Mar 2024, 9,554,757 trips, daily total fare. 54 days no incident, 2 verified real changes [17][18].</a:t>
+              <a:t>NYC yellow taxi trips, Jan to Mar 2024, 9,554,757 trips, daily total fare. 54 days no incident, 2 real changes, no fault found [17][18].</a:t>
             </a:r>
             <a:endParaRPr lang="en-US" sz="1200" dirty="0"/>
           </a:p>

</xml_diff>

<commit_message>
Update the pitch deck with the 29 Oct numbers
</commit_message>
<xml_diff>
--- a/docs/Receipts_ExaThon_2026_Deck.pptx
+++ b/docs/Receipts_ExaThon_2026_Deck.pptx
@@ -136,38 +136,38 @@
   <p:extLst>
     <p:ext uri="{521415D9-36F7-43E2-AB2F-B90AF26B5E84}">
       <p14:sectionLst xmlns:p14="http://schemas.microsoft.com/office/powerpoint/2010/main">
-        <p14:section name="Opening" id="{87476889-f31a-f551-18ab-14b0ffb99f29}">
+        <p14:section name="Opening" id="{0e27c936-b7a7-9558-5b95-94f6aca4c4d6}">
           <p14:sldIdLst>
             <p14:sldId id="256"/>
             <p14:sldId id="257"/>
           </p14:sldIdLst>
         </p14:section>
-        <p14:section name="The problem" id="{959a0914-96e8-5fdc-e390-6bfcf740ce78}">
+        <p14:section name="The problem" id="{9d528073-5f98-eb14-90c0-d5637cf8adc4}">
           <p14:sldIdLst>
             <p14:sldId id="258"/>
             <p14:sldId id="259"/>
           </p14:sldIdLst>
         </p14:section>
-        <p14:section name="Landscape" id="{d035a2d7-b625-54e4-60c5-5bddf50d322b}">
+        <p14:section name="Landscape" id="{30c4810d-c89f-ca9f-5e0b-0b93182584ef}">
           <p14:sldIdLst>
             <p14:sldId id="260"/>
             <p14:sldId id="261"/>
           </p14:sldIdLst>
         </p14:section>
-        <p14:section name="How it works" id="{e5a3cf4c-f5ee-377a-a3f1-df98ce1a3784}">
+        <p14:section name="How it works" id="{dc1e7086-7d9d-36e7-6872-e716c2d3db5b}">
           <p14:sldIdLst>
             <p14:sldId id="262"/>
             <p14:sldId id="263"/>
           </p14:sldIdLst>
         </p14:section>
-        <p14:section name="Three cases" id="{8e1ab72c-d50f-d156-13ea-6d79b1967690}">
+        <p14:section name="Three cases" id="{8fb36216-e8be-5808-8d17-7a2653187417}">
           <p14:sldIdLst>
             <p14:sldId id="264"/>
             <p14:sldId id="265"/>
             <p14:sldId id="266"/>
           </p14:sldIdLst>
         </p14:section>
-        <p14:section name="Agents and Exasol" id="{5ec3c0b4-b476-9047-12e3-347d63404603}">
+        <p14:section name="Agents and Exasol" id="{15d4030b-3cd7-495d-be71-057f0b54d68f}">
           <p14:sldIdLst>
             <p14:sldId id="267"/>
             <p14:sldId id="268"/>
@@ -176,7 +176,7 @@
             <p14:sldId id="271"/>
           </p14:sldIdLst>
         </p14:section>
-        <p14:section name="Evidence" id="{9f3d54b9-039b-3715-06fc-42ce30c867f4}">
+        <p14:section name="Evidence" id="{c797ce4c-5019-7ac6-01fc-e337c2d26daf}">
           <p14:sldIdLst>
             <p14:sldId id="272"/>
             <p14:sldId id="273"/>
@@ -187,14 +187,14 @@
             <p14:sldId id="278"/>
           </p14:sldIdLst>
         </p14:section>
-        <p14:section name="Honesty and next steps" id="{6517da96-50cc-68d4-432c-a3eebb6c8350}">
+        <p14:section name="Honesty and next steps" id="{93f2098c-dac2-ae35-3d55-3297d68518d2}">
           <p14:sldIdLst>
             <p14:sldId id="279"/>
             <p14:sldId id="280"/>
             <p14:sldId id="281"/>
           </p14:sldIdLst>
         </p14:section>
-        <p14:section name="References" id="{900a5647-0024-7a8e-8cb2-9d8157824363}">
+        <p14:section name="References" id="{c0b83908-6bb6-3894-325f-bcee1b0f1e44}">
           <p14:sldIdLst>
             <p14:sldId id="282"/>
             <p14:sldId id="283"/>
@@ -541,7 +541,7 @@
                 </a:solidFill>
                 <a:latin typeface="+mn-lt"/>
               </a:rPr>
-              <a:t>Where one run went, ms (median of 4 repeats, 5.6 s)</a:t>
+              <a:t>Where one run went, ms (warm median, 3.2 s)</a:t>
             </a:r>
           </a:p>
         </c:rich>
@@ -603,9 +603,9 @@
           </c:dLbls>
           <c:cat>
             <c:multiLvlStrRef>
-              <c:f>Sheet1!$A$2:$A$8</c:f>
+              <c:f>Sheet1!$A$2:$A$7</c:f>
               <c:multiLvlStrCache>
-                <c:ptCount val="7"/>
+                <c:ptCount val="6"/>
                 <c:lvl>
                   <c:pt idx="0">
                     <c:v>Read candidate and history</c:v>
@@ -625,39 +625,33 @@
                   <c:pt idx="5">
                     <c:v>Undo each suspect</c:v>
                   </c:pt>
-                  <c:pt idx="6">
-                    <c:v>Write back</c:v>
-                  </c:pt>
                 </c:lvl>
               </c:multiLvlStrCache>
             </c:multiLvlStrRef>
           </c:cat>
           <c:val>
             <c:numRef>
-              <c:f>Sheet1!$B$2:$B$8</c:f>
+              <c:f>Sheet1!$B$2:$B$7</c:f>
               <c:numCache>
                 <c:formatCode>General</c:formatCode>
-                <c:ptCount val="7"/>
+                <c:ptCount val="6"/>
                 <c:pt idx="0">
-                  <c:v>166</c:v>
+                  <c:v>98</c:v>
                 </c:pt>
                 <c:pt idx="1">
-                  <c:v>890</c:v>
+                  <c:v>536</c:v>
                 </c:pt>
                 <c:pt idx="2">
-                  <c:v>46</c:v>
+                  <c:v>56</c:v>
                 </c:pt>
                 <c:pt idx="3">
-                  <c:v>1306</c:v>
+                  <c:v>669</c:v>
                 </c:pt>
                 <c:pt idx="4">
-                  <c:v>466</c:v>
+                  <c:v>235</c:v>
                 </c:pt>
                 <c:pt idx="5">
-                  <c:v>1420</c:v>
-                </c:pt>
-                <c:pt idx="6">
-                  <c:v>825</c:v>
+                  <c:v>981</c:v>
                 </c:pt>
               </c:numCache>
             </c:numRef>
@@ -738,7 +732,7 @@
         <c:axId val="2094734552"/>
         <c:scaling>
           <c:orientation val="minMax"/>
-          <c:max val="1900"/>
+          <c:max val="1250"/>
           <c:min val="0"/>
         </c:scaling>
         <c:delete val="1"/>
@@ -2788,16 +2782,16 @@
                 <c:formatCode>General</c:formatCode>
                 <c:ptCount val="4"/>
                 <c:pt idx="0">
-                  <c:v>9.1</c:v>
+                  <c:v>4.5</c:v>
                 </c:pt>
                 <c:pt idx="1">
-                  <c:v>14</c:v>
+                  <c:v>7.2</c:v>
                 </c:pt>
                 <c:pt idx="2">
-                  <c:v>18.4</c:v>
+                  <c:v>9</c:v>
                 </c:pt>
                 <c:pt idx="3">
-                  <c:v>27.5</c:v>
+                  <c:v>15.8</c:v>
                 </c:pt>
               </c:numCache>
             </c:numRef>
@@ -2878,7 +2872,7 @@
         <c:axId val="2094734552"/>
         <c:scaling>
           <c:orientation val="minMax"/>
-          <c:max val="33"/>
+          <c:max val="19"/>
           <c:min val="0"/>
         </c:scaling>
         <c:delete val="1"/>
@@ -10408,7 +10402,7 @@
                   <a:schemeClr val="tx1"/>
                 </a:solidFill>
               </a:rPr>
-              <a:t>On Exasol the audit log lists the sessions that read the number in the bad window. The stand-in keeps no query log and says so.</a:t>
+              <a:t>On Exasol the audit log lists the sessions that read the number in the bad window. The stand-in keeps no query log and says so. All 57 statements of one gate run matched the audit log, none missing [21].</a:t>
             </a:r>
             <a:endParaRPr lang="en-US" sz="1200" dirty="0"/>
           </a:p>
@@ -12528,7 +12522,7 @@
                   <a:srgbClr val="5B7684"/>
                 </a:solidFill>
               </a:rPr>
-              <a:t>Exasol Personal is free to use for one user and runs locally on Windows, macOS and Linux [10][11]. Timings: one idle laptop, 26 Oct 2026 [21].</a:t>
+              <a:t>Exasol Personal is free to use for one user and runs locally on Windows, macOS and Linux [10][11]. Timings: one laptop, 29 Oct 2026, gate without write-back [21].</a:t>
             </a:r>
             <a:endParaRPr lang="en-US" sz="1100" dirty="0"/>
           </a:p>
@@ -18002,7 +17996,7 @@
                 <a:ea typeface="+mj-lt" pitchFamily="34" charset="-122"/>
                 <a:cs typeface="+mj-lt" pitchFamily="34" charset="-120"/>
               </a:rPr>
-              <a:t>5.6 s</a:t>
+              <a:t>3.2 s</a:t>
             </a:r>
             <a:endParaRPr lang="en-US" sz="2400" dirty="0"/>
           </a:p>
@@ -18038,7 +18032,7 @@
                   <a:schemeClr val="tx1"/>
                 </a:solidFill>
               </a:rPr>
-              <a:t>median for the IST case on an idle laptop, 4 repeats (first run 6.6 s) [21]</a:t>
+              <a:t>warm median for the IST case on Exasol, 3 repeats (cold 3.4 s); the stand-in takes 0.65 s [21]</a:t>
             </a:r>
             <a:endParaRPr lang="en-US" sz="1200" dirty="0"/>
           </a:p>
@@ -18220,7 +18214,7 @@
                 <a:ea typeface="+mj-lt" pitchFamily="34" charset="-122"/>
                 <a:cs typeface="+mj-lt" pitchFamily="34" charset="-120"/>
               </a:rPr>
-              <a:t>353 MiB</a:t>
+              <a:t>344 MiB</a:t>
             </a:r>
             <a:endParaRPr lang="en-US" sz="2400" dirty="0"/>
           </a:p>
@@ -18292,7 +18286,7 @@
                   <a:srgbClr val="5B7684"/>
                 </a:solidFill>
               </a:rPr>
-              <a:t>Windows 11 laptop (Intel Core 5), Exasol Personal 2026.2.0-nano.3 in Podman on WSL2, about 7.7 GiB visible to the VM [15]. Scaling was measured on 24 Oct, before the unit tail check; the timings on 26 Oct. Largest size: 17.3 million payment rows. No claim beyond that.</a:t>
+              <a:t>Windows 11 laptop (Intel Core 5), Exasol Personal 2026.2.0-nano.3 in Podman on WSL2, about 7.7 GiB visible to the VM [15]. Scaling and the IST timings were measured on 29 Oct, after the unit tail check; the click-to-HELD time on 26 Oct. Largest size: 17.3 million payment rows. No claim beyond that.</a:t>
             </a:r>
             <a:endParaRPr lang="en-US" sz="1100" dirty="0"/>
           </a:p>
@@ -22901,6 +22895,150 @@
         <p:spPr>
           <a:xfrm>
             <a:off x="548640" y="3474720"/>
+            <a:ext cx="548640" cy="548640"/>
+          </a:xfrm>
+          <a:prstGeom prst="rect">
+            <a:avLst/>
+          </a:prstGeom>
+          <a:noFill/>
+          <a:ln/>
+        </p:spPr>
+        <p:txBody>
+          <a:bodyPr wrap="square" lIns="0" tIns="0" rIns="0" bIns="0" rtlCol="0" anchor="t"/>
+          <a:lstStyle/>
+          <a:p>
+            <a:pPr indent="0" marL="0">
+              <a:buNone/>
+            </a:pPr>
+            <a:r>
+              <a:rPr lang="en-US" sz="1200" b="1" dirty="0">
+                <a:solidFill>
+                  <a:schemeClr val="accent3"/>
+                </a:solidFill>
+              </a:rPr>
+              <a:t>[21]</a:t>
+            </a:r>
+            <a:endParaRPr lang="en-US" sz="1200" dirty="0"/>
+          </a:p>
+        </p:txBody>
+      </p:sp>
+      <p:sp>
+        <p:nvSpPr>
+          <p:cNvPr id="14" name="Text 12"/>
+          <p:cNvSpPr txBox="1"/>
+          <p:nvPr/>
+        </p:nvSpPr>
+        <p:spPr>
+          <a:xfrm>
+            <a:off x="1143000" y="3474720"/>
+            <a:ext cx="10424160" cy="548640"/>
+          </a:xfrm>
+          <a:prstGeom prst="rect">
+            <a:avLst/>
+          </a:prstGeom>
+          <a:noFill/>
+          <a:ln/>
+        </p:spPr>
+        <p:txBody>
+          <a:bodyPr wrap="square" lIns="0" tIns="0" rIns="0" bIns="0" rtlCol="0" anchor="t"/>
+          <a:lstStyle/>
+          <a:p>
+            <a:pPr indent="0" marL="0">
+              <a:buNone/>
+            </a:pPr>
+            <a:r>
+              <a:rPr lang="en-US" sz="1200" dirty="0">
+                <a:solidFill>
+                  <a:schemeClr val="tx1"/>
+                </a:solidFill>
+              </a:rPr>
+              <a:t>This project. samples/exasol/redteam_report.md and redteam_report_before.md, heldout_unit_before.md and heldout_unit_after.md, timings.md, scaling.md, bench.json, docs/BENCHMARKS.md and docs/AUDIT_MATCH.md.</a:t>
+            </a:r>
+            <a:endParaRPr lang="en-US" sz="1200" dirty="0"/>
+          </a:p>
+        </p:txBody>
+      </p:sp>
+      <p:sp>
+        <p:nvSpPr>
+          <p:cNvPr id="15" name="Text 13"/>
+          <p:cNvSpPr txBox="1"/>
+          <p:nvPr/>
+        </p:nvSpPr>
+        <p:spPr>
+          <a:xfrm>
+            <a:off x="548640" y="4114800"/>
+            <a:ext cx="548640" cy="548640"/>
+          </a:xfrm>
+          <a:prstGeom prst="rect">
+            <a:avLst/>
+          </a:prstGeom>
+          <a:noFill/>
+          <a:ln/>
+        </p:spPr>
+        <p:txBody>
+          <a:bodyPr wrap="square" lIns="0" tIns="0" rIns="0" bIns="0" rtlCol="0" anchor="t"/>
+          <a:lstStyle/>
+          <a:p>
+            <a:pPr indent="0" marL="0">
+              <a:buNone/>
+            </a:pPr>
+            <a:r>
+              <a:rPr lang="en-US" sz="1200" b="1" dirty="0">
+                <a:solidFill>
+                  <a:schemeClr val="accent3"/>
+                </a:solidFill>
+              </a:rPr>
+              <a:t>[22]</a:t>
+            </a:r>
+            <a:endParaRPr lang="en-US" sz="1200" dirty="0"/>
+          </a:p>
+        </p:txBody>
+      </p:sp>
+      <p:sp>
+        <p:nvSpPr>
+          <p:cNvPr id="16" name="Text 14"/>
+          <p:cNvSpPr txBox="1"/>
+          <p:nvPr/>
+        </p:nvSpPr>
+        <p:spPr>
+          <a:xfrm>
+            <a:off x="1143000" y="4114800"/>
+            <a:ext cx="10424160" cy="548640"/>
+          </a:xfrm>
+          <a:prstGeom prst="rect">
+            <a:avLst/>
+          </a:prstGeom>
+          <a:noFill/>
+          <a:ln/>
+        </p:spPr>
+        <p:txBody>
+          <a:bodyPr wrap="square" lIns="0" tIns="0" rIns="0" bIns="0" rtlCol="0" anchor="t"/>
+          <a:lstStyle/>
+          <a:p>
+            <a:pPr indent="0" marL="0">
+              <a:buNone/>
+            </a:pPr>
+            <a:r>
+              <a:rPr lang="en-US" sz="1200" dirty="0">
+                <a:solidFill>
+                  <a:schemeClr val="tx1"/>
+                </a:solidFill>
+              </a:rPr>
+              <a:t>This project. samples/exasol/wrongfix_report.md, samples/metrics_heldout_before.md and samples/exasol/metrics_heldout_after.md (configured metrics, held-out cases written before the fix).</a:t>
+            </a:r>
+            <a:endParaRPr lang="en-US" sz="1200" dirty="0"/>
+          </a:p>
+        </p:txBody>
+      </p:sp>
+      <p:sp>
+        <p:nvSpPr>
+          <p:cNvPr id="17" name="Text 15"/>
+          <p:cNvSpPr txBox="1"/>
+          <p:nvPr/>
+        </p:nvSpPr>
+        <p:spPr>
+          <a:xfrm>
+            <a:off x="548640" y="4754880"/>
             <a:ext cx="548640" cy="301752"/>
           </a:xfrm>
           <a:prstGeom prst="rect">
@@ -22922,7 +23060,7 @@
                   <a:schemeClr val="accent3"/>
                 </a:solidFill>
               </a:rPr>
-              <a:t>[21]</a:t>
+              <a:t>[23]</a:t>
             </a:r>
             <a:endParaRPr lang="en-US" sz="1200" dirty="0"/>
           </a:p>
@@ -22930,13 +23068,13 @@
       </p:sp>
       <p:sp>
         <p:nvSpPr>
-          <p:cNvPr id="14" name="Text 12"/>
-          <p:cNvSpPr txBox="1"/>
-          <p:nvPr/>
-        </p:nvSpPr>
-        <p:spPr>
-          <a:xfrm>
-            <a:off x="1143000" y="3474720"/>
+          <p:cNvPr id="18" name="Text 16"/>
+          <p:cNvSpPr txBox="1"/>
+          <p:nvPr/>
+        </p:nvSpPr>
+        <p:spPr>
+          <a:xfrm>
+            <a:off x="1143000" y="4754880"/>
             <a:ext cx="10424160" cy="301752"/>
           </a:xfrm>
           <a:prstGeom prst="rect">
@@ -22958,7 +23096,7 @@
                   <a:schemeClr val="tx1"/>
                 </a:solidFill>
               </a:rPr>
-              <a:t>This project. samples/exasol/redteam_report.md and redteam_report_before.md, heldout_unit_before.md and heldout_unit_after.md, timings.md, scaling.md.</a:t>
+              <a:t>This project. samples/exasol/live_checks.md, docs/MCP_REAL_RUN.md (real agent) and docs/MCP_PROTOCOL_RUN.md (no model).</a:t>
             </a:r>
             <a:endParaRPr lang="en-US" sz="1200" dirty="0"/>
           </a:p>
@@ -22966,157 +23104,13 @@
       </p:sp>
       <p:sp>
         <p:nvSpPr>
-          <p:cNvPr id="15" name="Text 13"/>
-          <p:cNvSpPr txBox="1"/>
-          <p:nvPr/>
-        </p:nvSpPr>
-        <p:spPr>
-          <a:xfrm>
-            <a:off x="548640" y="3867912"/>
-            <a:ext cx="548640" cy="548640"/>
-          </a:xfrm>
-          <a:prstGeom prst="rect">
-            <a:avLst/>
-          </a:prstGeom>
-          <a:noFill/>
-          <a:ln/>
-        </p:spPr>
-        <p:txBody>
-          <a:bodyPr wrap="square" lIns="0" tIns="0" rIns="0" bIns="0" rtlCol="0" anchor="t"/>
-          <a:lstStyle/>
-          <a:p>
-            <a:pPr indent="0" marL="0">
-              <a:buNone/>
-            </a:pPr>
-            <a:r>
-              <a:rPr lang="en-US" sz="1200" b="1" dirty="0">
-                <a:solidFill>
-                  <a:schemeClr val="accent3"/>
-                </a:solidFill>
-              </a:rPr>
-              <a:t>[22]</a:t>
-            </a:r>
-            <a:endParaRPr lang="en-US" sz="1200" dirty="0"/>
-          </a:p>
-        </p:txBody>
-      </p:sp>
-      <p:sp>
-        <p:nvSpPr>
-          <p:cNvPr id="16" name="Text 14"/>
-          <p:cNvSpPr txBox="1"/>
-          <p:nvPr/>
-        </p:nvSpPr>
-        <p:spPr>
-          <a:xfrm>
-            <a:off x="1143000" y="3867912"/>
-            <a:ext cx="10424160" cy="548640"/>
-          </a:xfrm>
-          <a:prstGeom prst="rect">
-            <a:avLst/>
-          </a:prstGeom>
-          <a:noFill/>
-          <a:ln/>
-        </p:spPr>
-        <p:txBody>
-          <a:bodyPr wrap="square" lIns="0" tIns="0" rIns="0" bIns="0" rtlCol="0" anchor="t"/>
-          <a:lstStyle/>
-          <a:p>
-            <a:pPr indent="0" marL="0">
-              <a:buNone/>
-            </a:pPr>
-            <a:r>
-              <a:rPr lang="en-US" sz="1200" dirty="0">
-                <a:solidFill>
-                  <a:schemeClr val="tx1"/>
-                </a:solidFill>
-              </a:rPr>
-              <a:t>This project. samples/exasol/wrongfix_report.md, samples/metrics_heldout_before.md and samples/exasol/metrics_heldout_after.md (configured metrics, held-out cases written before the fix).</a:t>
-            </a:r>
-            <a:endParaRPr lang="en-US" sz="1200" dirty="0"/>
-          </a:p>
-        </p:txBody>
-      </p:sp>
-      <p:sp>
-        <p:nvSpPr>
-          <p:cNvPr id="17" name="Text 15"/>
-          <p:cNvSpPr txBox="1"/>
-          <p:nvPr/>
-        </p:nvSpPr>
-        <p:spPr>
-          <a:xfrm>
-            <a:off x="548640" y="4507992"/>
-            <a:ext cx="548640" cy="301752"/>
-          </a:xfrm>
-          <a:prstGeom prst="rect">
-            <a:avLst/>
-          </a:prstGeom>
-          <a:noFill/>
-          <a:ln/>
-        </p:spPr>
-        <p:txBody>
-          <a:bodyPr wrap="square" lIns="0" tIns="0" rIns="0" bIns="0" rtlCol="0" anchor="t"/>
-          <a:lstStyle/>
-          <a:p>
-            <a:pPr indent="0" marL="0">
-              <a:buNone/>
-            </a:pPr>
-            <a:r>
-              <a:rPr lang="en-US" sz="1200" b="1" dirty="0">
-                <a:solidFill>
-                  <a:schemeClr val="accent3"/>
-                </a:solidFill>
-              </a:rPr>
-              <a:t>[23]</a:t>
-            </a:r>
-            <a:endParaRPr lang="en-US" sz="1200" dirty="0"/>
-          </a:p>
-        </p:txBody>
-      </p:sp>
-      <p:sp>
-        <p:nvSpPr>
-          <p:cNvPr id="18" name="Text 16"/>
-          <p:cNvSpPr txBox="1"/>
-          <p:nvPr/>
-        </p:nvSpPr>
-        <p:spPr>
-          <a:xfrm>
-            <a:off x="1143000" y="4507992"/>
-            <a:ext cx="10424160" cy="301752"/>
-          </a:xfrm>
-          <a:prstGeom prst="rect">
-            <a:avLst/>
-          </a:prstGeom>
-          <a:noFill/>
-          <a:ln/>
-        </p:spPr>
-        <p:txBody>
-          <a:bodyPr wrap="square" lIns="0" tIns="0" rIns="0" bIns="0" rtlCol="0" anchor="t"/>
-          <a:lstStyle/>
-          <a:p>
-            <a:pPr indent="0" marL="0">
-              <a:buNone/>
-            </a:pPr>
-            <a:r>
-              <a:rPr lang="en-US" sz="1200" dirty="0">
-                <a:solidFill>
-                  <a:schemeClr val="tx1"/>
-                </a:solidFill>
-              </a:rPr>
-              <a:t>This project. samples/exasol/live_checks.md, docs/MCP_REAL_RUN.md (real agent) and docs/MCP_PROTOCOL_RUN.md (no model).</a:t>
-            </a:r>
-            <a:endParaRPr lang="en-US" sz="1200" dirty="0"/>
-          </a:p>
-        </p:txBody>
-      </p:sp>
-      <p:sp>
-        <p:nvSpPr>
           <p:cNvPr id="19" name="Text 17"/>
           <p:cNvSpPr txBox="1"/>
           <p:nvPr/>
         </p:nvSpPr>
         <p:spPr>
           <a:xfrm>
-            <a:off x="548640" y="5120640"/>
+            <a:off x="548640" y="5285232"/>
             <a:ext cx="11064240" cy="640080"/>
           </a:xfrm>
           <a:prstGeom prst="rect">

</xml_diff>

<commit_message>
Update the deck with the 25-seed red team result
</commit_message>
<xml_diff>
--- a/docs/Receipts_ExaThon_2026_Deck.pptx
+++ b/docs/Receipts_ExaThon_2026_Deck.pptx
@@ -136,38 +136,38 @@
   <p:extLst>
     <p:ext uri="{521415D9-36F7-43E2-AB2F-B90AF26B5E84}">
       <p14:sectionLst xmlns:p14="http://schemas.microsoft.com/office/powerpoint/2010/main">
-        <p14:section name="Opening" id="{0e27c936-b7a7-9558-5b95-94f6aca4c4d6}">
+        <p14:section name="Opening" id="{b95b30ba-7068-c7ba-46f7-22a78cacd62c}">
           <p14:sldIdLst>
             <p14:sldId id="256"/>
             <p14:sldId id="257"/>
           </p14:sldIdLst>
         </p14:section>
-        <p14:section name="The problem" id="{9d528073-5f98-eb14-90c0-d5637cf8adc4}">
+        <p14:section name="The problem" id="{46a4f181-8e73-b1fc-b6ce-0f086d606279}">
           <p14:sldIdLst>
             <p14:sldId id="258"/>
             <p14:sldId id="259"/>
           </p14:sldIdLst>
         </p14:section>
-        <p14:section name="Landscape" id="{30c4810d-c89f-ca9f-5e0b-0b93182584ef}">
+        <p14:section name="Landscape" id="{fda25270-e6d5-eab2-2afb-71945b933694}">
           <p14:sldIdLst>
             <p14:sldId id="260"/>
             <p14:sldId id="261"/>
           </p14:sldIdLst>
         </p14:section>
-        <p14:section name="How it works" id="{dc1e7086-7d9d-36e7-6872-e716c2d3db5b}">
+        <p14:section name="How it works" id="{32a411e2-8539-f99f-d348-d0026ad8ed86}">
           <p14:sldIdLst>
             <p14:sldId id="262"/>
             <p14:sldId id="263"/>
           </p14:sldIdLst>
         </p14:section>
-        <p14:section name="Three cases" id="{8fb36216-e8be-5808-8d17-7a2653187417}">
+        <p14:section name="Three cases" id="{76bbe4cb-bf55-6960-084d-2691af32de94}">
           <p14:sldIdLst>
             <p14:sldId id="264"/>
             <p14:sldId id="265"/>
             <p14:sldId id="266"/>
           </p14:sldIdLst>
         </p14:section>
-        <p14:section name="Agents and Exasol" id="{15d4030b-3cd7-495d-be71-057f0b54d68f}">
+        <p14:section name="Agents and Exasol" id="{bde9f0c7-543f-665a-4c5a-7e872d95e405}">
           <p14:sldIdLst>
             <p14:sldId id="267"/>
             <p14:sldId id="268"/>
@@ -176,7 +176,7 @@
             <p14:sldId id="271"/>
           </p14:sldIdLst>
         </p14:section>
-        <p14:section name="Evidence" id="{c797ce4c-5019-7ac6-01fc-e337c2d26daf}">
+        <p14:section name="Evidence" id="{e3eb195a-4ed4-6076-d2d9-ec62480d69ff}">
           <p14:sldIdLst>
             <p14:sldId id="272"/>
             <p14:sldId id="273"/>
@@ -187,14 +187,14 @@
             <p14:sldId id="278"/>
           </p14:sldIdLst>
         </p14:section>
-        <p14:section name="Honesty and next steps" id="{93f2098c-dac2-ae35-3d55-3297d68518d2}">
+        <p14:section name="Honesty and next steps" id="{c8e50f22-2306-a9ab-ee46-ac0571cc1bcd}">
           <p14:sldIdLst>
             <p14:sldId id="279"/>
             <p14:sldId id="280"/>
             <p14:sldId id="281"/>
           </p14:sldIdLst>
         </p14:section>
-        <p14:section name="References" id="{c0b83908-6bb6-3894-325f-bcee1b0f1e44}">
+        <p14:section name="References" id="{5f2d6c4d-ad36-b0b9-2f90-81bd773adff8}">
           <p14:sldIdLst>
             <p14:sldId id="282"/>
             <p14:sldId id="283"/>
@@ -13728,7 +13728,7 @@
                   <a:schemeClr val="bg1"/>
                 </a:solidFill>
               </a:rPr>
-              <a:t>We attacked our own gate, found a hole, and closed it</a:t>
+              <a:t>We attacked our own gate: fixed one hole, found more</a:t>
             </a:r>
             <a:endParaRPr lang="en-US" sz="3400" dirty="0"/>
           </a:p>
@@ -14029,13 +14029,13 @@
             <a:r>
               <a:rPr lang="en-US" sz="1700" b="1" dirty="0">
                 <a:solidFill>
-                  <a:schemeClr val="accent3"/>
+                  <a:schemeClr val="accent2"/>
                 </a:solidFill>
                 <a:latin typeface="+mj-lt" pitchFamily="34" charset="0"/>
                 <a:ea typeface="+mj-lt" pitchFamily="34" charset="-122"/>
                 <a:cs typeface="+mj-lt" pitchFamily="34" charset="-120"/>
               </a:rPr>
-              <a:t>After</a:t>
+              <a:t>Then 25 seeds</a:t>
             </a:r>
             <a:endParaRPr lang="en-US" sz="1700" dirty="0"/>
           </a:p>
@@ -14071,7 +14071,7 @@
                   <a:schemeClr val="tx1"/>
                 </a:solidFill>
               </a:rPr>
-              <a:t>0 holes. Held-out partial unit cases: 0 of 24 proven before, 12 of 24 after. The 50-run eval is still 50 of 50, and the real taxi days are unchanged [21].</a:t>
+              <a:t>Seed 11: 0 holes, and held-out partial unit cases went from 0 of 24 proven to 12. Over 25 seeds the red team found 13 holes, all partial clock shifts on one gateway: 25% of its rows moves revenue about 4% and goes out as no incident. Not closed [21].</a:t>
             </a:r>
             <a:endParaRPr lang="en-US" sz="1200" dirty="0"/>
           </a:p>
@@ -14107,7 +14107,7 @@
                   <a:srgbClr val="5B7684"/>
                 </a:solidFill>
               </a:rPr>
-              <a:t>Stale FX feed is all or nothing and was caught. Exasol, seed 11, 20,000 orders a day. The held-out cases were written before the fix. Not closed: x10 errors on 2% to 10% of a gateway are held, not proven [21].</a:t>
+              <a:t>Chart: Exasol, seed 11, 20,000 orders a day; floors vary by seed (the unit change is proven down to 2% on 20 of 25 seeds). Stale FX feed is all or nothing and was caught. Not closed: partial clock shifts, and x10 errors on 2% to 10% of a gateway are held, not proven [21].</a:t>
             </a:r>
             <a:endParaRPr lang="en-US" sz="1100" dirty="0"/>
           </a:p>

</xml_diff>

<commit_message>
Tighten slide 19 wording on the red team holes
</commit_message>
<xml_diff>
--- a/docs/Receipts_ExaThon_2026_Deck.pptx
+++ b/docs/Receipts_ExaThon_2026_Deck.pptx
@@ -136,38 +136,38 @@
   <p:extLst>
     <p:ext uri="{521415D9-36F7-43E2-AB2F-B90AF26B5E84}">
       <p14:sectionLst xmlns:p14="http://schemas.microsoft.com/office/powerpoint/2010/main">
-        <p14:section name="Opening" id="{b95b30ba-7068-c7ba-46f7-22a78cacd62c}">
+        <p14:section name="Opening" id="{95076ff9-541a-3f0c-0984-b68d6c932c19}">
           <p14:sldIdLst>
             <p14:sldId id="256"/>
             <p14:sldId id="257"/>
           </p14:sldIdLst>
         </p14:section>
-        <p14:section name="The problem" id="{46a4f181-8e73-b1fc-b6ce-0f086d606279}">
+        <p14:section name="The problem" id="{8067a3b9-8aa7-3558-b844-71c2a0c4a4cf}">
           <p14:sldIdLst>
             <p14:sldId id="258"/>
             <p14:sldId id="259"/>
           </p14:sldIdLst>
         </p14:section>
-        <p14:section name="Landscape" id="{fda25270-e6d5-eab2-2afb-71945b933694}">
+        <p14:section name="Landscape" id="{e9fab96b-b2bc-917b-06d8-72077b2b720f}">
           <p14:sldIdLst>
             <p14:sldId id="260"/>
             <p14:sldId id="261"/>
           </p14:sldIdLst>
         </p14:section>
-        <p14:section name="How it works" id="{32a411e2-8539-f99f-d348-d0026ad8ed86}">
+        <p14:section name="How it works" id="{78d445fd-82e6-f745-4276-254a03b06996}">
           <p14:sldIdLst>
             <p14:sldId id="262"/>
             <p14:sldId id="263"/>
           </p14:sldIdLst>
         </p14:section>
-        <p14:section name="Three cases" id="{76bbe4cb-bf55-6960-084d-2691af32de94}">
+        <p14:section name="Three cases" id="{e42a25ab-6c18-200b-558f-116d32409964}">
           <p14:sldIdLst>
             <p14:sldId id="264"/>
             <p14:sldId id="265"/>
             <p14:sldId id="266"/>
           </p14:sldIdLst>
         </p14:section>
-        <p14:section name="Agents and Exasol" id="{bde9f0c7-543f-665a-4c5a-7e872d95e405}">
+        <p14:section name="Agents and Exasol" id="{5fbcb0e9-30aa-edbc-fe58-3ecb42815ead}">
           <p14:sldIdLst>
             <p14:sldId id="267"/>
             <p14:sldId id="268"/>
@@ -176,7 +176,7 @@
             <p14:sldId id="271"/>
           </p14:sldIdLst>
         </p14:section>
-        <p14:section name="Evidence" id="{e3eb195a-4ed4-6076-d2d9-ec62480d69ff}">
+        <p14:section name="Evidence" id="{c08dc035-9c87-8507-512f-f378effb608a}">
           <p14:sldIdLst>
             <p14:sldId id="272"/>
             <p14:sldId id="273"/>
@@ -187,14 +187,14 @@
             <p14:sldId id="278"/>
           </p14:sldIdLst>
         </p14:section>
-        <p14:section name="Honesty and next steps" id="{c8e50f22-2306-a9ab-ee46-ac0571cc1bcd}">
+        <p14:section name="Honesty and next steps" id="{46e2e8cb-d87a-6dfc-6041-fbb7fc1c4c93}">
           <p14:sldIdLst>
             <p14:sldId id="279"/>
             <p14:sldId id="280"/>
             <p14:sldId id="281"/>
           </p14:sldIdLst>
         </p14:section>
-        <p14:section name="References" id="{5f2d6c4d-ad36-b0b9-2f90-81bd773adff8}">
+        <p14:section name="References" id="{2e563cff-b781-6176-7cb4-b5a3b8f7f418}">
           <p14:sldIdLst>
             <p14:sldId id="282"/>
             <p14:sldId id="283"/>
@@ -14071,7 +14071,7 @@
                   <a:schemeClr val="tx1"/>
                 </a:solidFill>
               </a:rPr>
-              <a:t>Seed 11: 0 holes, and held-out partial unit cases went from 0 of 24 proven to 12. Over 25 seeds the red team found 13 holes, all partial clock shifts on one gateway: 25% of its rows moves revenue about 4% and goes out as no incident. Not closed [21].</a:t>
+              <a:t>Seed 11: 0 holes. Over 25 seeds the red team found 13 holes, all partial clock shifts on one gateway: 25% to 50% of its rows moves revenue only 4% to 8% and goes out as no incident. Not closed [21].</a:t>
             </a:r>
             <a:endParaRPr lang="en-US" sz="1200" dirty="0"/>
           </a:p>
@@ -14107,7 +14107,7 @@
                   <a:srgbClr val="5B7684"/>
                 </a:solidFill>
               </a:rPr>
-              <a:t>Chart: Exasol, seed 11, 20,000 orders a day; floors vary by seed (the unit change is proven down to 2% on 20 of 25 seeds). Stale FX feed is all or nothing and was caught. Not closed: partial clock shifts, and x10 errors on 2% to 10% of a gateway are held, not proven [21].</a:t>
+              <a:t>Chart: Exasol, seed 11, 20,000 orders a day; floors vary by seed. Stale FX is all or nothing and was caught. Not closed: partial clock shifts can go out as no incident (13 holes: 10 at 25%, 3 at 50%); x10 errors on 2% to 10% of a gateway are held, not proven [21].</a:t>
             </a:r>
             <a:endParaRPr lang="en-US" sz="1100" dirty="0"/>
           </a:p>

</xml_diff>